<commit_message>
refactor: use dynamic scoped slots for custom node rendering in main branch
</commit_message>
<xml_diff>
--- a/Vue-Flow-Tutorial.pptx
+++ b/Vue-Flow-Tutorial.pptx
@@ -10612,13 +10612,13 @@
             <a:pPr algn="l">
               <a:defRPr sz="1200" b="0">
                 <a:solidFill>
-                  <a:srgbClr val="FBBF24"/>
+                  <a:srgbClr val="34D399"/>
                 </a:solidFill>
                 <a:latin typeface="Calibri"/>
               </a:defRPr>
             </a:pPr>
             <a:r>
-              <a:t>⚠️ 記得使用 markRaw() 包裝元件，避免效能問題</a:t>
+              <a:t>💡 推薦使用作用域插槽，代碼更簡潔且無須手動註冊</a:t>
             </a:r>
           </a:p>
         </p:txBody>
@@ -10705,29 +10705,92 @@
             <a:r>
               <a:rPr sz="1100">
                 <a:solidFill>
-                  <a:srgbClr val="C084FC"/>
-                </a:solidFill>
-                <a:latin typeface="Consolas"/>
-              </a:rPr>
-              <a:t>const </a:t>
-            </a:r>
-            <a:r>
-              <a:rPr sz="1100">
-                <a:solidFill>
-                  <a:srgbClr val="D4D4D8"/>
-                </a:solidFill>
-                <a:latin typeface="Consolas"/>
-              </a:rPr>
-              <a:t>nodeTypes </a:t>
-            </a:r>
-            <a:r>
-              <a:rPr sz="1100">
-                <a:solidFill>
-                  <a:srgbClr val="D4D4D8"/>
-                </a:solidFill>
-                <a:latin typeface="Consolas"/>
-              </a:rPr>
-              <a:t>= {</a:t>
+                  <a:srgbClr val="D4D4D8"/>
+                </a:solidFill>
+                <a:latin typeface="Consolas"/>
+              </a:rPr>
+              <a:t>&lt;</a:t>
+            </a:r>
+            <a:r>
+              <a:rPr sz="1100">
+                <a:solidFill>
+                  <a:srgbClr val="FB7185"/>
+                </a:solidFill>
+                <a:latin typeface="Consolas"/>
+              </a:rPr>
+              <a:t>VueFlow </a:t>
+            </a:r>
+            <a:r>
+              <a:rPr sz="1100">
+                <a:solidFill>
+                  <a:srgbClr val="818CF8"/>
+                </a:solidFill>
+                <a:latin typeface="Consolas"/>
+              </a:rPr>
+              <a:t>:nodes</a:t>
+            </a:r>
+            <a:r>
+              <a:rPr sz="1100">
+                <a:solidFill>
+                  <a:srgbClr val="D4D4D8"/>
+                </a:solidFill>
+                <a:latin typeface="Consolas"/>
+              </a:rPr>
+              <a:t>=</a:t>
+            </a:r>
+            <a:r>
+              <a:rPr sz="1100">
+                <a:solidFill>
+                  <a:srgbClr val="34D399"/>
+                </a:solidFill>
+                <a:latin typeface="Consolas"/>
+              </a:rPr>
+              <a:t>"nodes"</a:t>
+            </a:r>
+            <a:r>
+              <a:rPr sz="1100">
+                <a:solidFill>
+                  <a:srgbClr val="D4D4D8"/>
+                </a:solidFill>
+                <a:latin typeface="Consolas"/>
+              </a:rPr>
+              <a:t> </a:t>
+            </a:r>
+            <a:r>
+              <a:rPr sz="1100">
+                <a:solidFill>
+                  <a:srgbClr val="818CF8"/>
+                </a:solidFill>
+                <a:latin typeface="Consolas"/>
+              </a:rPr>
+              <a:t>:edges</a:t>
+            </a:r>
+            <a:r>
+              <a:rPr sz="1100">
+                <a:solidFill>
+                  <a:srgbClr val="D4D4D8"/>
+                </a:solidFill>
+                <a:latin typeface="Consolas"/>
+              </a:rPr>
+              <a:t>=</a:t>
+            </a:r>
+            <a:r>
+              <a:rPr sz="1100">
+                <a:solidFill>
+                  <a:srgbClr val="34D399"/>
+                </a:solidFill>
+                <a:latin typeface="Consolas"/>
+              </a:rPr>
+              <a:t>"edges"</a:t>
+            </a:r>
+            <a:r>
+              <a:rPr sz="1100">
+                <a:solidFill>
+                  <a:srgbClr val="D4D4D8"/>
+                </a:solidFill>
+                <a:latin typeface="Consolas"/>
+              </a:rPr>
+              <a:t>&gt;</a:t>
             </a:r>
           </a:p>
           <a:p>
@@ -10749,25 +10812,16 @@
                 </a:solidFill>
                 <a:latin typeface="Consolas"/>
               </a:rPr>
-              <a:t>  custom: </a:t>
-            </a:r>
-            <a:r>
-              <a:rPr sz="1100">
-                <a:solidFill>
-                  <a:srgbClr val="FBBF24"/>
-                </a:solidFill>
-                <a:latin typeface="Consolas"/>
-              </a:rPr>
-              <a:t>markRaw</a:t>
-            </a:r>
-            <a:r>
-              <a:rPr sz="1100">
-                <a:solidFill>
-                  <a:srgbClr val="D4D4D8"/>
-                </a:solidFill>
-                <a:latin typeface="Consolas"/>
-              </a:rPr>
-              <a:t>(CustomNode)</a:t>
+              <a:t>  </a:t>
+            </a:r>
+            <a:r>
+              <a:rPr sz="1100">
+                <a:solidFill>
+                  <a:srgbClr val="686888"/>
+                </a:solidFill>
+                <a:latin typeface="Consolas"/>
+              </a:rPr>
+              <a:t>&lt;!-- 💡 使用 #node-&lt;type&gt; 作用域插槽 --&gt;</a:t>
             </a:r>
           </a:p>
           <a:p>
@@ -10789,7 +10843,52 @@
                 </a:solidFill>
                 <a:latin typeface="Consolas"/>
               </a:rPr>
-              <a:t>}</a:t>
+              <a:t>  &lt;</a:t>
+            </a:r>
+            <a:r>
+              <a:rPr sz="1100">
+                <a:solidFill>
+                  <a:srgbClr val="FB7185"/>
+                </a:solidFill>
+                <a:latin typeface="Consolas"/>
+              </a:rPr>
+              <a:t>template </a:t>
+            </a:r>
+            <a:r>
+              <a:rPr sz="1100">
+                <a:solidFill>
+                  <a:srgbClr val="818CF8"/>
+                </a:solidFill>
+                <a:latin typeface="Consolas"/>
+              </a:rPr>
+              <a:t>#node-custom</a:t>
+            </a:r>
+            <a:r>
+              <a:rPr sz="1100">
+                <a:solidFill>
+                  <a:srgbClr val="D4D4D8"/>
+                </a:solidFill>
+                <a:latin typeface="Consolas"/>
+              </a:rPr>
+              <a:t>=</a:t>
+            </a:r>
+            <a:r>
+              <a:rPr sz="1100">
+                <a:solidFill>
+                  <a:srgbClr val="34D399"/>
+                </a:solidFill>
+                <a:latin typeface="Consolas"/>
+              </a:rPr>
+              <a:t>"nodeProps"</a:t>
+            </a:r>
+            <a:r>
+              <a:rPr sz="1100">
+                <a:solidFill>
+                  <a:srgbClr val="D4D4D8"/>
+                </a:solidFill>
+                <a:latin typeface="Consolas"/>
+              </a:rPr>
+              <a:t>&gt;</a:t>
             </a:r>
           </a:p>
           <a:p>
@@ -10811,7 +10910,52 @@
                 </a:solidFill>
                 <a:latin typeface="Consolas"/>
               </a:rPr>
-              <a:t/>
+              <a:t>    &lt;</a:t>
+            </a:r>
+            <a:r>
+              <a:rPr sz="1100">
+                <a:solidFill>
+                  <a:srgbClr val="FB7185"/>
+                </a:solidFill>
+                <a:latin typeface="Consolas"/>
+              </a:rPr>
+              <a:t>CustomNode </a:t>
+            </a:r>
+            <a:r>
+              <a:rPr sz="1100">
+                <a:solidFill>
+                  <a:srgbClr val="818CF8"/>
+                </a:solidFill>
+                <a:latin typeface="Consolas"/>
+              </a:rPr>
+              <a:t>v-bind</a:t>
+            </a:r>
+            <a:r>
+              <a:rPr sz="1100">
+                <a:solidFill>
+                  <a:srgbClr val="D4D4D8"/>
+                </a:solidFill>
+                <a:latin typeface="Consolas"/>
+              </a:rPr>
+              <a:t>=</a:t>
+            </a:r>
+            <a:r>
+              <a:rPr sz="1100">
+                <a:solidFill>
+                  <a:srgbClr val="34D399"/>
+                </a:solidFill>
+                <a:latin typeface="Consolas"/>
+              </a:rPr>
+              <a:t>"nodeProps"</a:t>
+            </a:r>
+            <a:r>
+              <a:rPr sz="1100">
+                <a:solidFill>
+                  <a:srgbClr val="D4D4D8"/>
+                </a:solidFill>
+                <a:latin typeface="Consolas"/>
+              </a:rPr>
+              <a:t> /&gt;</a:t>
             </a:r>
           </a:p>
           <a:p>
@@ -10833,7 +10977,7 @@
                 </a:solidFill>
                 <a:latin typeface="Consolas"/>
               </a:rPr>
-              <a:t>&lt;</a:t>
+              <a:t>  &lt;/</a:t>
             </a:r>
             <a:r>
               <a:rPr sz="1100">
@@ -10842,7 +10986,16 @@
                 </a:solidFill>
                 <a:latin typeface="Consolas"/>
               </a:rPr>
-              <a:t>VueFlow</a:t>
+              <a:t>template</a:t>
+            </a:r>
+            <a:r>
+              <a:rPr sz="1100">
+                <a:solidFill>
+                  <a:srgbClr val="D4D4D8"/>
+                </a:solidFill>
+                <a:latin typeface="Consolas"/>
+              </a:rPr>
+              <a:t>&gt;</a:t>
             </a:r>
           </a:p>
           <a:p>
@@ -10860,91 +11013,29 @@
             <a:r>
               <a:rPr sz="1100">
                 <a:solidFill>
-                  <a:srgbClr val="818CF8"/>
-                </a:solidFill>
-                <a:latin typeface="Consolas"/>
-              </a:rPr>
-              <a:t>  :node-types</a:t>
-            </a:r>
-            <a:r>
-              <a:rPr sz="1100">
-                <a:solidFill>
-                  <a:srgbClr val="D4D4D8"/>
-                </a:solidFill>
-                <a:latin typeface="Consolas"/>
-              </a:rPr>
-              <a:t>=</a:t>
-            </a:r>
-            <a:r>
-              <a:rPr sz="1100">
-                <a:solidFill>
-                  <a:srgbClr val="34D399"/>
-                </a:solidFill>
-                <a:latin typeface="Consolas"/>
-              </a:rPr>
-              <a:t>"nodeTypes"</a:t>
-            </a:r>
-          </a:p>
-          <a:p>
-            <a:pPr>
-              <a:lnSpc>
-                <a:spcPts val="1800"/>
-              </a:lnSpc>
-              <a:spcBef>
-                <a:spcPts val="0"/>
-              </a:spcBef>
-              <a:spcAft>
-                <a:spcPts val="0"/>
-              </a:spcAft>
-            </a:pPr>
-            <a:r>
-              <a:rPr sz="1100">
-                <a:solidFill>
-                  <a:srgbClr val="818CF8"/>
-                </a:solidFill>
-                <a:latin typeface="Consolas"/>
-              </a:rPr>
-              <a:t>  v-model:nodes</a:t>
-            </a:r>
-            <a:r>
-              <a:rPr sz="1100">
-                <a:solidFill>
-                  <a:srgbClr val="D4D4D8"/>
-                </a:solidFill>
-                <a:latin typeface="Consolas"/>
-              </a:rPr>
-              <a:t>=</a:t>
-            </a:r>
-            <a:r>
-              <a:rPr sz="1100">
-                <a:solidFill>
-                  <a:srgbClr val="34D399"/>
-                </a:solidFill>
-                <a:latin typeface="Consolas"/>
-              </a:rPr>
-              <a:t>"nodes"</a:t>
-            </a:r>
-          </a:p>
-          <a:p>
-            <a:pPr>
-              <a:lnSpc>
-                <a:spcPts val="1800"/>
-              </a:lnSpc>
-              <a:spcBef>
-                <a:spcPts val="0"/>
-              </a:spcBef>
-              <a:spcAft>
-                <a:spcPts val="0"/>
-              </a:spcAft>
-            </a:pPr>
-            <a:r>
-              <a:rPr sz="1100">
-                <a:solidFill>
-                  <a:srgbClr val="D4D4D8"/>
-                </a:solidFill>
-                <a:latin typeface="Consolas"/>
-              </a:rPr>
-              <a:t>/&gt;</a:t>
+                  <a:srgbClr val="D4D4D8"/>
+                </a:solidFill>
+                <a:latin typeface="Consolas"/>
+              </a:rPr>
+              <a:t>&lt;/</a:t>
+            </a:r>
+            <a:r>
+              <a:rPr sz="1100">
+                <a:solidFill>
+                  <a:srgbClr val="FB7185"/>
+                </a:solidFill>
+                <a:latin typeface="Consolas"/>
+              </a:rPr>
+              <a:t>VueFlow</a:t>
+            </a:r>
+            <a:r>
+              <a:rPr sz="1100">
+                <a:solidFill>
+                  <a:srgbClr val="D4D4D8"/>
+                </a:solidFill>
+                <a:latin typeface="Consolas"/>
+              </a:rPr>
+              <a:t>&gt;</a:t>
             </a:r>
           </a:p>
         </p:txBody>

</xml_diff>